<commit_message>
Add orientation video link to the presentation's closing slide
</commit_message>
<xml_diff>
--- a/docs/Threadline-AIORI3-PS021.pptx
+++ b/docs/Threadline-AIORI3-PS021.pptx
@@ -7087,8 +7087,8 @@
         </p:nvSpPr>
         <p:spPr>
           <a:xfrm>
-            <a:off x="548640" y="4069080"/>
-            <a:ext cx="3474720" cy="960120"/>
+            <a:off x="548640" y="4023360"/>
+            <a:ext cx="2651760" cy="1097280"/>
           </a:xfrm>
           <a:prstGeom prst="roundRect">
             <a:avLst>
@@ -7133,8 +7133,8 @@
         </p:nvSpPr>
         <p:spPr>
           <a:xfrm>
-            <a:off x="548640" y="4114800"/>
-            <a:ext cx="3474720" cy="914400"/>
+            <a:off x="621792" y="4069080"/>
+            <a:ext cx="2505456" cy="1005840"/>
           </a:xfrm>
           <a:prstGeom prst="rect">
             <a:avLst/>
@@ -7161,11 +7161,12 @@
           <a:p>
             <a:pPr algn="ctr"/>
             <a:r>
-              <a:rPr sz="1300" b="0" i="0">
+              <a:rPr sz="1200" b="0" i="0">
                 <a:solidFill>
                   <a:srgbClr val="111111"/>
                 </a:solidFill>
                 <a:latin typeface="Calibri"/>
+                <a:hlinkClick r:id="rId3"/>
               </a:rPr>
               <a:t>github.com/yugrajmangate-dev/A3-PS021-TC516</a:t>
             </a:r>
@@ -7180,8 +7181,8 @@
         </p:nvSpPr>
         <p:spPr>
           <a:xfrm>
-            <a:off x="4297679" y="4069080"/>
-            <a:ext cx="3474720" cy="960120"/>
+            <a:off x="3355848" y="4023360"/>
+            <a:ext cx="2651760" cy="1097280"/>
           </a:xfrm>
           <a:prstGeom prst="roundRect">
             <a:avLst>
@@ -7226,8 +7227,8 @@
         </p:nvSpPr>
         <p:spPr>
           <a:xfrm>
-            <a:off x="4297679" y="4114800"/>
-            <a:ext cx="3474720" cy="914400"/>
+            <a:off x="3429000" y="4069080"/>
+            <a:ext cx="2505456" cy="1005840"/>
           </a:xfrm>
           <a:prstGeom prst="rect">
             <a:avLst/>
@@ -7254,11 +7255,12 @@
           <a:p>
             <a:pPr algn="ctr"/>
             <a:r>
-              <a:rPr sz="1300" b="0" i="0">
+              <a:rPr sz="1200" b="0" i="0">
                 <a:solidFill>
                   <a:srgbClr val="111111"/>
                 </a:solidFill>
                 <a:latin typeface="Calibri"/>
+                <a:hlinkClick r:id="rId4"/>
               </a:rPr>
               <a:t>threadline-brown.vercel.app</a:t>
             </a:r>
@@ -7273,8 +7275,8 @@
         </p:nvSpPr>
         <p:spPr>
           <a:xfrm>
-            <a:off x="8046719" y="4069080"/>
-            <a:ext cx="3474720" cy="960120"/>
+            <a:off x="6163055" y="4023360"/>
+            <a:ext cx="2651760" cy="1097280"/>
           </a:xfrm>
           <a:prstGeom prst="roundRect">
             <a:avLst>
@@ -7319,8 +7321,8 @@
         </p:nvSpPr>
         <p:spPr>
           <a:xfrm>
-            <a:off x="8046719" y="4114800"/>
-            <a:ext cx="3474720" cy="914400"/>
+            <a:off x="6236207" y="4069080"/>
+            <a:ext cx="2505456" cy="1005840"/>
           </a:xfrm>
           <a:prstGeom prst="rect">
             <a:avLst/>
@@ -7341,13 +7343,107 @@
                 </a:solidFill>
                 <a:latin typeface="Calibri"/>
               </a:rPr>
+              <a:t>Orientation video</a:t>
+            </a:r>
+          </a:p>
+          <a:p>
+            <a:pPr algn="ctr"/>
+            <a:r>
+              <a:rPr sz="1200" b="0" i="0">
+                <a:solidFill>
+                  <a:srgbClr val="111111"/>
+                </a:solidFill>
+                <a:latin typeface="Calibri"/>
+                <a:hlinkClick r:id="rId5"/>
+              </a:rPr>
+              <a:t>youtu.be/4IXSzTUrEOA</a:t>
+            </a:r>
+          </a:p>
+        </p:txBody>
+      </p:sp>
+      <p:sp>
+        <p:nvSpPr>
+          <p:cNvPr id="11" name="Rounded Rectangle 10"/>
+          <p:cNvSpPr/>
+          <p:nvPr/>
+        </p:nvSpPr>
+        <p:spPr>
+          <a:xfrm>
+            <a:off x="8970263" y="4023360"/>
+            <a:ext cx="2651760" cy="1097280"/>
+          </a:xfrm>
+          <a:prstGeom prst="roundRect">
+            <a:avLst>
+              <a:gd name="adj" fmla="val 8000"/>
+            </a:avLst>
+          </a:prstGeom>
+          <a:solidFill>
+            <a:srgbClr val="EEF0FF"/>
+          </a:solidFill>
+          <a:ln>
+            <a:noFill/>
+          </a:ln>
+          <a:effectLst/>
+        </p:spPr>
+        <p:style>
+          <a:lnRef idx="1">
+            <a:schemeClr val="accent1"/>
+          </a:lnRef>
+          <a:fillRef idx="3">
+            <a:schemeClr val="accent1"/>
+          </a:fillRef>
+          <a:effectRef idx="2">
+            <a:schemeClr val="accent1"/>
+          </a:effectRef>
+          <a:fontRef idx="minor">
+            <a:schemeClr val="lt1"/>
+          </a:fontRef>
+        </p:style>
+        <p:txBody>
+          <a:bodyPr rtlCol="0" anchor="ctr"/>
+          <a:lstStyle/>
+          <a:p>
+            <a:pPr algn="ctr"/>
+          </a:p>
+        </p:txBody>
+      </p:sp>
+      <p:sp>
+        <p:nvSpPr>
+          <p:cNvPr id="12" name="TextBox 11"/>
+          <p:cNvSpPr txBox="1"/>
+          <p:nvPr/>
+        </p:nvSpPr>
+        <p:spPr>
+          <a:xfrm>
+            <a:off x="9043415" y="4069080"/>
+            <a:ext cx="2505456" cy="1005840"/>
+          </a:xfrm>
+          <a:prstGeom prst="rect">
+            <a:avLst/>
+          </a:prstGeom>
+          <a:noFill/>
+        </p:spPr>
+        <p:txBody>
+          <a:bodyPr wrap="square" anchor="ctr" lIns="0" rIns="0" tIns="0" bIns="0">
+            <a:spAutoFit/>
+          </a:bodyPr>
+          <a:lstStyle/>
+          <a:p>
+            <a:pPr algn="ctr"/>
+            <a:r>
+              <a:rPr sz="1500" b="1" i="0">
+                <a:solidFill>
+                  <a:srgbClr val="1A236E"/>
+                </a:solidFill>
+                <a:latin typeface="Calibri"/>
+              </a:rPr>
               <a:t>Run locally</a:t>
             </a:r>
           </a:p>
           <a:p>
             <a:pPr algn="ctr"/>
             <a:r>
-              <a:rPr sz="1300" b="0" i="0">
+              <a:rPr sz="1200" b="0" i="0">
                 <a:solidFill>
                   <a:srgbClr val="111111"/>
                 </a:solidFill>
@@ -7360,7 +7456,7 @@
       </p:sp>
       <p:sp>
         <p:nvSpPr>
-          <p:cNvPr id="11" name="Footer"/>
+          <p:cNvPr id="13" name="Footer"/>
           <p:cNvSpPr txBox="1"/>
           <p:nvPr/>
         </p:nvSpPr>
@@ -7413,7 +7509,7 @@
       </p:sp>
       <p:sp>
         <p:nvSpPr>
-          <p:cNvPr id="12" name="Slide number"/>
+          <p:cNvPr id="14" name="Slide number"/>
           <p:cNvSpPr txBox="1"/>
           <p:nvPr/>
         </p:nvSpPr>

</xml_diff>

<commit_message>
Add member emails to the title slide and a src/ code map per the AIORI template
</commit_message>
<xml_diff>
--- a/docs/Threadline-AIORI3-PS021.pptx
+++ b/docs/Threadline-AIORI3-PS021.pptx
@@ -4437,13 +4437,13 @@
               </a:spcAft>
             </a:pPr>
             <a:r>
-              <a:rPr sz="1400" b="0" i="0">
-                <a:solidFill>
-                  <a:srgbClr val="555B6E"/>
-                </a:solidFill>
-                <a:latin typeface="Calibri"/>
-              </a:rPr>
-              <a:t>github.com/yugrajmangate-dev</a:t>
+              <a:rPr sz="1500" b="1" i="0">
+                <a:solidFill>
+                  <a:srgbClr val="111111"/>
+                </a:solidFill>
+                <a:latin typeface="Calibri"/>
+              </a:rPr>
+              <a:t>yugrajmangate@gmail.com</a:t>
             </a:r>
           </a:p>
           <a:p>
@@ -4459,32 +4459,9 @@
                 </a:solidFill>
                 <a:latin typeface="Calibri"/>
               </a:rPr>
-              <a:t>Backend, API, SQLite persistence, coordination</a:t>
-            </a:r>
-          </a:p>
-        </p:txBody>
-      </p:sp>
-      <p:sp>
-        <p:nvSpPr>
-          <p:cNvPr id="8" name="TextBox 7"/>
-          <p:cNvSpPr txBox="1"/>
-          <p:nvPr/>
-        </p:nvSpPr>
-        <p:spPr>
-          <a:xfrm>
-            <a:off x="6035040" y="4892040"/>
-            <a:ext cx="5486400" cy="1280160"/>
-          </a:xfrm>
-          <a:prstGeom prst="rect">
-            <a:avLst/>
-          </a:prstGeom>
-          <a:noFill/>
-        </p:spPr>
-        <p:txBody>
-          <a:bodyPr wrap="square" anchor="t" lIns="0" rIns="0" tIns="0" bIns="0">
-            <a:spAutoFit/>
-          </a:bodyPr>
-          <a:lstStyle/>
+              <a:t>github.com/yugrajmangate-dev</a:t>
+            </a:r>
+          </a:p>
           <a:p>
             <a:pPr algn="l">
               <a:spcAft>
@@ -4492,6 +4469,45 @@
               </a:spcAft>
             </a:pPr>
             <a:r>
+              <a:rPr sz="1400" b="0" i="0">
+                <a:solidFill>
+                  <a:srgbClr val="555B6E"/>
+                </a:solidFill>
+                <a:latin typeface="Calibri"/>
+              </a:rPr>
+              <a:t>Backend, API, SQLite persistence, coordination</a:t>
+            </a:r>
+          </a:p>
+        </p:txBody>
+      </p:sp>
+      <p:sp>
+        <p:nvSpPr>
+          <p:cNvPr id="8" name="TextBox 7"/>
+          <p:cNvSpPr txBox="1"/>
+          <p:nvPr/>
+        </p:nvSpPr>
+        <p:spPr>
+          <a:xfrm>
+            <a:off x="6035040" y="4892040"/>
+            <a:ext cx="5486400" cy="1280160"/>
+          </a:xfrm>
+          <a:prstGeom prst="rect">
+            <a:avLst/>
+          </a:prstGeom>
+          <a:noFill/>
+        </p:spPr>
+        <p:txBody>
+          <a:bodyPr wrap="square" anchor="t" lIns="0" rIns="0" tIns="0" bIns="0">
+            <a:spAutoFit/>
+          </a:bodyPr>
+          <a:lstStyle/>
+          <a:p>
+            <a:pPr algn="l">
+              <a:spcAft>
+                <a:spcPts val="200"/>
+              </a:spcAft>
+            </a:pPr>
+            <a:r>
               <a:rPr sz="1800" b="1" i="0">
                 <a:solidFill>
                   <a:srgbClr val="111111"/>
@@ -4499,6 +4515,22 @@
                 <a:latin typeface="Calibri"/>
               </a:rPr>
               <a:t>Neha Niphade</a:t>
+            </a:r>
+          </a:p>
+          <a:p>
+            <a:pPr algn="l">
+              <a:spcAft>
+                <a:spcPts val="200"/>
+              </a:spcAft>
+            </a:pPr>
+            <a:r>
+              <a:rPr sz="1500" b="1" i="0">
+                <a:solidFill>
+                  <a:srgbClr val="111111"/>
+                </a:solidFill>
+                <a:latin typeface="Calibri"/>
+              </a:rPr>
+              <a:t>nehapniphade@proton.me</a:t>
             </a:r>
           </a:p>
           <a:p>

</xml_diff>

<commit_message>
Point repository links at aiori-hackathon after the ownership transfer
Updates README (badge, links, repository access), docs and the deck's
code links. The old yugrajmangate-dev URL redirects, so nothing breaks.
</commit_message>
<xml_diff>
--- a/docs/Threadline-AIORI3-PS021.pptx
+++ b/docs/Threadline-AIORI3-PS021.pptx
@@ -4677,7 +4677,7 @@
                 </a:solidFill>
                 <a:latin typeface="Calibri"/>
               </a:rPr>
-              <a:t>Code: github.com/yugrajmangate-dev/A3-PS021-TC516  ·  Live demo: threadline-brown.vercel.app</a:t>
+              <a:t>Code: github.com/aiori-hackathon/A3-PS021-TC516  ·  Live demo: threadline-brown.vercel.app</a:t>
             </a:r>
           </a:p>
         </p:txBody>
@@ -9542,7 +9542,7 @@
                 <a:latin typeface="Calibri"/>
                 <a:hlinkClick r:id="rId3"/>
               </a:rPr>
-              <a:t>github.com/yugrajmangate-dev/A3-PS021-TC516</a:t>
+              <a:t>github.com/aiori-hackathon/A3-PS021-TC516</a:t>
             </a:r>
           </a:p>
         </p:txBody>

</xml_diff>